<commit_message>
adding sketch for IECP VECTO model
</commit_message>
<xml_diff>
--- a/Documentation/User Manual Source/material User Manual.pptx
+++ b/Documentation/User Manual Source/material User Manual.pptx
@@ -30,6 +30,7 @@
     <p:sldId id="311" r:id="rId24"/>
     <p:sldId id="312" r:id="rId25"/>
     <p:sldId id="313" r:id="rId26"/>
+    <p:sldId id="316" r:id="rId27"/>
   </p:sldIdLst>
   <p:sldSz cx="13355638" cy="6858000"/>
   <p:notesSz cx="7099300" cy="10234613"/>
@@ -5209,7 +5210,7 @@
           <a:p>
             <a:fld id="{11A2203D-8DA4-4655-BF9E-AA17BDE25312}" type="datetimeFigureOut">
               <a:rPr lang="en-GB" smtClean="0"/>
-              <a:t>26/01/2021</a:t>
+              <a:t>15/06/2022</a:t>
             </a:fld>
             <a:endParaRPr lang="en-GB"/>
           </a:p>
@@ -5379,7 +5380,7 @@
           <a:p>
             <a:fld id="{11A2203D-8DA4-4655-BF9E-AA17BDE25312}" type="datetimeFigureOut">
               <a:rPr lang="en-GB" smtClean="0"/>
-              <a:t>26/01/2021</a:t>
+              <a:t>15/06/2022</a:t>
             </a:fld>
             <a:endParaRPr lang="en-GB"/>
           </a:p>
@@ -5559,7 +5560,7 @@
           <a:p>
             <a:fld id="{11A2203D-8DA4-4655-BF9E-AA17BDE25312}" type="datetimeFigureOut">
               <a:rPr lang="en-GB" smtClean="0"/>
-              <a:t>26/01/2021</a:t>
+              <a:t>15/06/2022</a:t>
             </a:fld>
             <a:endParaRPr lang="en-GB"/>
           </a:p>
@@ -5729,7 +5730,7 @@
           <a:p>
             <a:fld id="{11A2203D-8DA4-4655-BF9E-AA17BDE25312}" type="datetimeFigureOut">
               <a:rPr lang="en-GB" smtClean="0"/>
-              <a:t>26/01/2021</a:t>
+              <a:t>15/06/2022</a:t>
             </a:fld>
             <a:endParaRPr lang="en-GB"/>
           </a:p>
@@ -5975,7 +5976,7 @@
           <a:p>
             <a:fld id="{11A2203D-8DA4-4655-BF9E-AA17BDE25312}" type="datetimeFigureOut">
               <a:rPr lang="en-GB" smtClean="0"/>
-              <a:t>26/01/2021</a:t>
+              <a:t>15/06/2022</a:t>
             </a:fld>
             <a:endParaRPr lang="en-GB"/>
           </a:p>
@@ -6263,7 +6264,7 @@
           <a:p>
             <a:fld id="{11A2203D-8DA4-4655-BF9E-AA17BDE25312}" type="datetimeFigureOut">
               <a:rPr lang="en-GB" smtClean="0"/>
-              <a:t>26/01/2021</a:t>
+              <a:t>15/06/2022</a:t>
             </a:fld>
             <a:endParaRPr lang="en-GB"/>
           </a:p>
@@ -6685,7 +6686,7 @@
           <a:p>
             <a:fld id="{11A2203D-8DA4-4655-BF9E-AA17BDE25312}" type="datetimeFigureOut">
               <a:rPr lang="en-GB" smtClean="0"/>
-              <a:t>26/01/2021</a:t>
+              <a:t>15/06/2022</a:t>
             </a:fld>
             <a:endParaRPr lang="en-GB"/>
           </a:p>
@@ -6803,7 +6804,7 @@
           <a:p>
             <a:fld id="{11A2203D-8DA4-4655-BF9E-AA17BDE25312}" type="datetimeFigureOut">
               <a:rPr lang="en-GB" smtClean="0"/>
-              <a:t>26/01/2021</a:t>
+              <a:t>15/06/2022</a:t>
             </a:fld>
             <a:endParaRPr lang="en-GB"/>
           </a:p>
@@ -6898,7 +6899,7 @@
           <a:p>
             <a:fld id="{11A2203D-8DA4-4655-BF9E-AA17BDE25312}" type="datetimeFigureOut">
               <a:rPr lang="en-GB" smtClean="0"/>
-              <a:t>26/01/2021</a:t>
+              <a:t>15/06/2022</a:t>
             </a:fld>
             <a:endParaRPr lang="en-GB"/>
           </a:p>
@@ -7175,7 +7176,7 @@
           <a:p>
             <a:fld id="{11A2203D-8DA4-4655-BF9E-AA17BDE25312}" type="datetimeFigureOut">
               <a:rPr lang="en-GB" smtClean="0"/>
-              <a:t>26/01/2021</a:t>
+              <a:t>15/06/2022</a:t>
             </a:fld>
             <a:endParaRPr lang="en-GB"/>
           </a:p>
@@ -7428,7 +7429,7 @@
           <a:p>
             <a:fld id="{11A2203D-8DA4-4655-BF9E-AA17BDE25312}" type="datetimeFigureOut">
               <a:rPr lang="en-GB" smtClean="0"/>
-              <a:t>26/01/2021</a:t>
+              <a:t>15/06/2022</a:t>
             </a:fld>
             <a:endParaRPr lang="en-GB"/>
           </a:p>
@@ -7644,7 +7645,7 @@
           <a:p>
             <a:fld id="{11A2203D-8DA4-4655-BF9E-AA17BDE25312}" type="datetimeFigureOut">
               <a:rPr lang="en-GB" smtClean="0"/>
-              <a:t>26/01/2021</a:t>
+              <a:t>15/06/2022</a:t>
             </a:fld>
             <a:endParaRPr lang="en-GB"/>
           </a:p>
@@ -30964,6 +30965,832 @@
 </p:sld>
 </file>
 
+<file path=ppt/slides/slide26.xml><?xml version="1.0" encoding="utf-8"?>
+<p:sld xmlns:a="http://schemas.openxmlformats.org/drawingml/2006/main" xmlns:r="http://schemas.openxmlformats.org/officeDocument/2006/relationships" xmlns:p="http://schemas.openxmlformats.org/presentationml/2006/main">
+  <p:cSld>
+    <p:spTree>
+      <p:nvGrpSpPr>
+        <p:cNvPr id="1" name=""/>
+        <p:cNvGrpSpPr/>
+        <p:nvPr/>
+      </p:nvGrpSpPr>
+      <p:grpSpPr>
+        <a:xfrm>
+          <a:off x="0" y="0"/>
+          <a:ext cx="0" cy="0"/>
+          <a:chOff x="0" y="0"/>
+          <a:chExt cx="0" cy="0"/>
+        </a:xfrm>
+      </p:grpSpPr>
+      <p:sp>
+        <p:nvSpPr>
+          <p:cNvPr id="4" name="Rechteck 3">
+            <a:extLst>
+              <a:ext uri="{FF2B5EF4-FFF2-40B4-BE49-F238E27FC236}">
+                <a16:creationId xmlns:a16="http://schemas.microsoft.com/office/drawing/2014/main" id="{85A11934-CD2B-4C73-9EB9-0392BD588544}"/>
+              </a:ext>
+            </a:extLst>
+          </p:cNvPr>
+          <p:cNvSpPr/>
+          <p:nvPr/>
+        </p:nvSpPr>
+        <p:spPr>
+          <a:xfrm>
+            <a:off x="2890373" y="1844824"/>
+            <a:ext cx="5515638" cy="2160237"/>
+          </a:xfrm>
+          <a:prstGeom prst="rect">
+            <a:avLst/>
+          </a:prstGeom>
+          <a:noFill/>
+          <a:ln w="28575"/>
+        </p:spPr>
+        <p:style>
+          <a:lnRef idx="2">
+            <a:schemeClr val="accent1">
+              <a:shade val="50000"/>
+            </a:schemeClr>
+          </a:lnRef>
+          <a:fillRef idx="1">
+            <a:schemeClr val="accent1"/>
+          </a:fillRef>
+          <a:effectRef idx="0">
+            <a:schemeClr val="accent1"/>
+          </a:effectRef>
+          <a:fontRef idx="minor">
+            <a:schemeClr val="lt1"/>
+          </a:fontRef>
+        </p:style>
+        <p:txBody>
+          <a:bodyPr rtlCol="0" anchor="ctr"/>
+          <a:lstStyle/>
+          <a:p>
+            <a:pPr algn="ctr"/>
+            <a:endParaRPr lang="de-AT"/>
+          </a:p>
+        </p:txBody>
+      </p:sp>
+      <p:sp>
+        <p:nvSpPr>
+          <p:cNvPr id="5" name="Rechteck 4">
+            <a:extLst>
+              <a:ext uri="{FF2B5EF4-FFF2-40B4-BE49-F238E27FC236}">
+                <a16:creationId xmlns:a16="http://schemas.microsoft.com/office/drawing/2014/main" id="{4355C51A-E78D-42C4-82F1-8CF3588D5E57}"/>
+              </a:ext>
+            </a:extLst>
+          </p:cNvPr>
+          <p:cNvSpPr/>
+          <p:nvPr/>
+        </p:nvSpPr>
+        <p:spPr>
+          <a:xfrm>
+            <a:off x="3581475" y="2353072"/>
+            <a:ext cx="1440160" cy="1287760"/>
+          </a:xfrm>
+          <a:prstGeom prst="rect">
+            <a:avLst/>
+          </a:prstGeom>
+          <a:noFill/>
+          <a:ln w="28575"/>
+        </p:spPr>
+        <p:style>
+          <a:lnRef idx="2">
+            <a:schemeClr val="accent1">
+              <a:shade val="50000"/>
+            </a:schemeClr>
+          </a:lnRef>
+          <a:fillRef idx="1">
+            <a:schemeClr val="accent1"/>
+          </a:fillRef>
+          <a:effectRef idx="0">
+            <a:schemeClr val="accent1"/>
+          </a:effectRef>
+          <a:fontRef idx="minor">
+            <a:schemeClr val="lt1"/>
+          </a:fontRef>
+        </p:style>
+        <p:txBody>
+          <a:bodyPr rtlCol="0" anchor="ctr"/>
+          <a:lstStyle/>
+          <a:p>
+            <a:pPr algn="ctr"/>
+            <a:endParaRPr lang="de-AT"/>
+          </a:p>
+        </p:txBody>
+      </p:sp>
+      <p:sp>
+        <p:nvSpPr>
+          <p:cNvPr id="6" name="Textfeld 5">
+            <a:extLst>
+              <a:ext uri="{FF2B5EF4-FFF2-40B4-BE49-F238E27FC236}">
+                <a16:creationId xmlns:a16="http://schemas.microsoft.com/office/drawing/2014/main" id="{813FEC6F-78C4-477F-8B2B-A5E8F1B4A434}"/>
+              </a:ext>
+            </a:extLst>
+          </p:cNvPr>
+          <p:cNvSpPr txBox="1"/>
+          <p:nvPr/>
+        </p:nvSpPr>
+        <p:spPr>
+          <a:xfrm>
+            <a:off x="2890373" y="1327048"/>
+            <a:ext cx="1013419" cy="584775"/>
+          </a:xfrm>
+          <a:prstGeom prst="rect">
+            <a:avLst/>
+          </a:prstGeom>
+          <a:noFill/>
+        </p:spPr>
+        <p:txBody>
+          <a:bodyPr wrap="none" rtlCol="0">
+            <a:spAutoFit/>
+          </a:bodyPr>
+          <a:lstStyle/>
+          <a:p>
+            <a:r>
+              <a:rPr lang="en-US" sz="3200" dirty="0">
+                <a:solidFill>
+                  <a:schemeClr val="tx2">
+                    <a:lumMod val="75000"/>
+                  </a:schemeClr>
+                </a:solidFill>
+              </a:rPr>
+              <a:t>IEPC </a:t>
+            </a:r>
+            <a:endParaRPr lang="de-AT" sz="3200" dirty="0">
+              <a:solidFill>
+                <a:schemeClr val="tx2">
+                  <a:lumMod val="75000"/>
+                </a:schemeClr>
+              </a:solidFill>
+            </a:endParaRPr>
+          </a:p>
+        </p:txBody>
+      </p:sp>
+      <p:sp>
+        <p:nvSpPr>
+          <p:cNvPr id="7" name="Textfeld 6">
+            <a:extLst>
+              <a:ext uri="{FF2B5EF4-FFF2-40B4-BE49-F238E27FC236}">
+                <a16:creationId xmlns:a16="http://schemas.microsoft.com/office/drawing/2014/main" id="{4550088C-9932-45DE-8946-D854E3DEFFF4}"/>
+              </a:ext>
+            </a:extLst>
+          </p:cNvPr>
+          <p:cNvSpPr txBox="1"/>
+          <p:nvPr/>
+        </p:nvSpPr>
+        <p:spPr>
+          <a:xfrm>
+            <a:off x="3489164" y="1952962"/>
+            <a:ext cx="1532471" cy="400110"/>
+          </a:xfrm>
+          <a:prstGeom prst="rect">
+            <a:avLst/>
+          </a:prstGeom>
+          <a:noFill/>
+        </p:spPr>
+        <p:txBody>
+          <a:bodyPr wrap="none" rtlCol="0">
+            <a:spAutoFit/>
+          </a:bodyPr>
+          <a:lstStyle/>
+          <a:p>
+            <a:r>
+              <a:rPr lang="en-US" sz="2000" dirty="0">
+                <a:solidFill>
+                  <a:schemeClr val="tx2">
+                    <a:lumMod val="75000"/>
+                  </a:schemeClr>
+                </a:solidFill>
+              </a:rPr>
+              <a:t>Transmission</a:t>
+            </a:r>
+            <a:endParaRPr lang="de-AT" sz="2000" dirty="0">
+              <a:solidFill>
+                <a:schemeClr val="tx2">
+                  <a:lumMod val="75000"/>
+                </a:schemeClr>
+              </a:solidFill>
+            </a:endParaRPr>
+          </a:p>
+        </p:txBody>
+      </p:sp>
+      <p:sp>
+        <p:nvSpPr>
+          <p:cNvPr id="8" name="Rechteck 7">
+            <a:extLst>
+              <a:ext uri="{FF2B5EF4-FFF2-40B4-BE49-F238E27FC236}">
+                <a16:creationId xmlns:a16="http://schemas.microsoft.com/office/drawing/2014/main" id="{C858528B-736E-4BF5-BCB5-2CF06A50660D}"/>
+              </a:ext>
+            </a:extLst>
+          </p:cNvPr>
+          <p:cNvSpPr/>
+          <p:nvPr/>
+        </p:nvSpPr>
+        <p:spPr>
+          <a:xfrm>
+            <a:off x="6461795" y="2353072"/>
+            <a:ext cx="1440160" cy="1287760"/>
+          </a:xfrm>
+          <a:prstGeom prst="rect">
+            <a:avLst/>
+          </a:prstGeom>
+          <a:noFill/>
+          <a:ln w="28575"/>
+        </p:spPr>
+        <p:style>
+          <a:lnRef idx="2">
+            <a:schemeClr val="accent1">
+              <a:shade val="50000"/>
+            </a:schemeClr>
+          </a:lnRef>
+          <a:fillRef idx="1">
+            <a:schemeClr val="accent1"/>
+          </a:fillRef>
+          <a:effectRef idx="0">
+            <a:schemeClr val="accent1"/>
+          </a:effectRef>
+          <a:fontRef idx="minor">
+            <a:schemeClr val="lt1"/>
+          </a:fontRef>
+        </p:style>
+        <p:txBody>
+          <a:bodyPr rtlCol="0" anchor="ctr"/>
+          <a:lstStyle/>
+          <a:p>
+            <a:pPr algn="ctr"/>
+            <a:endParaRPr lang="de-AT"/>
+          </a:p>
+        </p:txBody>
+      </p:sp>
+      <p:sp>
+        <p:nvSpPr>
+          <p:cNvPr id="9" name="Textfeld 8">
+            <a:extLst>
+              <a:ext uri="{FF2B5EF4-FFF2-40B4-BE49-F238E27FC236}">
+                <a16:creationId xmlns:a16="http://schemas.microsoft.com/office/drawing/2014/main" id="{CBE3F935-433A-483B-AE09-6C0964B8D6D9}"/>
+              </a:ext>
+            </a:extLst>
+          </p:cNvPr>
+          <p:cNvSpPr txBox="1"/>
+          <p:nvPr/>
+        </p:nvSpPr>
+        <p:spPr>
+          <a:xfrm>
+            <a:off x="6369484" y="1952962"/>
+            <a:ext cx="1671355" cy="400110"/>
+          </a:xfrm>
+          <a:prstGeom prst="rect">
+            <a:avLst/>
+          </a:prstGeom>
+          <a:noFill/>
+        </p:spPr>
+        <p:txBody>
+          <a:bodyPr wrap="none" rtlCol="0">
+            <a:spAutoFit/>
+          </a:bodyPr>
+          <a:lstStyle/>
+          <a:p>
+            <a:r>
+              <a:rPr lang="en-US" sz="2000" dirty="0">
+                <a:solidFill>
+                  <a:schemeClr val="tx2">
+                    <a:lumMod val="75000"/>
+                  </a:schemeClr>
+                </a:solidFill>
+              </a:rPr>
+              <a:t>Electric Motor</a:t>
+            </a:r>
+            <a:endParaRPr lang="de-AT" sz="2000" dirty="0">
+              <a:solidFill>
+                <a:schemeClr val="tx2">
+                  <a:lumMod val="75000"/>
+                </a:schemeClr>
+              </a:solidFill>
+            </a:endParaRPr>
+          </a:p>
+        </p:txBody>
+      </p:sp>
+      <p:cxnSp>
+        <p:nvCxnSpPr>
+          <p:cNvPr id="11" name="Gerader Verbinder 10">
+            <a:extLst>
+              <a:ext uri="{FF2B5EF4-FFF2-40B4-BE49-F238E27FC236}">
+                <a16:creationId xmlns:a16="http://schemas.microsoft.com/office/drawing/2014/main" id="{4C662400-5909-4D0E-BA65-78EB75269044}"/>
+              </a:ext>
+            </a:extLst>
+          </p:cNvPr>
+          <p:cNvCxnSpPr>
+            <a:cxnSpLocks/>
+            <a:endCxn id="5" idx="1"/>
+          </p:cNvCxnSpPr>
+          <p:nvPr/>
+        </p:nvCxnSpPr>
+        <p:spPr>
+          <a:xfrm>
+            <a:off x="2141315" y="2996952"/>
+            <a:ext cx="1440160" cy="0"/>
+          </a:xfrm>
+          <a:prstGeom prst="line">
+            <a:avLst/>
+          </a:prstGeom>
+          <a:ln w="76200">
+            <a:headEnd type="stealth"/>
+          </a:ln>
+        </p:spPr>
+        <p:style>
+          <a:lnRef idx="1">
+            <a:schemeClr val="accent1"/>
+          </a:lnRef>
+          <a:fillRef idx="0">
+            <a:schemeClr val="accent1"/>
+          </a:fillRef>
+          <a:effectRef idx="0">
+            <a:schemeClr val="accent1"/>
+          </a:effectRef>
+          <a:fontRef idx="minor">
+            <a:schemeClr val="tx1"/>
+          </a:fontRef>
+        </p:style>
+      </p:cxnSp>
+      <p:cxnSp>
+        <p:nvCxnSpPr>
+          <p:cNvPr id="13" name="Gerader Verbinder 12">
+            <a:extLst>
+              <a:ext uri="{FF2B5EF4-FFF2-40B4-BE49-F238E27FC236}">
+                <a16:creationId xmlns:a16="http://schemas.microsoft.com/office/drawing/2014/main" id="{45EB623F-F0E2-4735-A9FB-6EA41B32C310}"/>
+              </a:ext>
+            </a:extLst>
+          </p:cNvPr>
+          <p:cNvCxnSpPr>
+            <a:cxnSpLocks/>
+            <a:stCxn id="5" idx="3"/>
+            <a:endCxn id="8" idx="1"/>
+          </p:cNvCxnSpPr>
+          <p:nvPr/>
+        </p:nvCxnSpPr>
+        <p:spPr>
+          <a:xfrm>
+            <a:off x="5021635" y="2996952"/>
+            <a:ext cx="1440160" cy="0"/>
+          </a:xfrm>
+          <a:prstGeom prst="line">
+            <a:avLst/>
+          </a:prstGeom>
+          <a:ln w="76200">
+            <a:headEnd type="stealth"/>
+          </a:ln>
+        </p:spPr>
+        <p:style>
+          <a:lnRef idx="1">
+            <a:schemeClr val="accent1"/>
+          </a:lnRef>
+          <a:fillRef idx="0">
+            <a:schemeClr val="accent1"/>
+          </a:fillRef>
+          <a:effectRef idx="0">
+            <a:schemeClr val="accent1"/>
+          </a:effectRef>
+          <a:fontRef idx="minor">
+            <a:schemeClr val="tx1"/>
+          </a:fontRef>
+        </p:style>
+      </p:cxnSp>
+      <p:pic>
+        <p:nvPicPr>
+          <p:cNvPr id="15" name="Grafik 14" descr="Zahnräder">
+            <a:extLst>
+              <a:ext uri="{FF2B5EF4-FFF2-40B4-BE49-F238E27FC236}">
+                <a16:creationId xmlns:a16="http://schemas.microsoft.com/office/drawing/2014/main" id="{C83FA5BA-DEA9-469F-9A84-4609E6D58EC6}"/>
+              </a:ext>
+            </a:extLst>
+          </p:cNvPr>
+          <p:cNvPicPr>
+            <a:picLocks noChangeAspect="1"/>
+          </p:cNvPicPr>
+          <p:nvPr/>
+        </p:nvPicPr>
+        <p:blipFill>
+          <a:blip r:embed="rId2">
+            <a:extLst>
+              <a:ext uri="{28A0092B-C50C-407E-A947-70E740481C1C}">
+                <a14:useLocalDpi xmlns:a14="http://schemas.microsoft.com/office/drawing/2010/main" val="0"/>
+              </a:ext>
+              <a:ext uri="{96DAC541-7B7A-43D3-8B79-37D633B846F1}">
+                <asvg:svgBlip xmlns:asvg="http://schemas.microsoft.com/office/drawing/2016/SVG/main" r:embed="rId3"/>
+              </a:ext>
+            </a:extLst>
+          </a:blip>
+          <a:stretch>
+            <a:fillRect/>
+          </a:stretch>
+        </p:blipFill>
+        <p:spPr>
+          <a:xfrm>
+            <a:off x="3798199" y="2636912"/>
+            <a:ext cx="914400" cy="914400"/>
+          </a:xfrm>
+          <a:prstGeom prst="rect">
+            <a:avLst/>
+          </a:prstGeom>
+        </p:spPr>
+      </p:pic>
+      <p:sp>
+        <p:nvSpPr>
+          <p:cNvPr id="16" name="Textfeld 15">
+            <a:extLst>
+              <a:ext uri="{FF2B5EF4-FFF2-40B4-BE49-F238E27FC236}">
+                <a16:creationId xmlns:a16="http://schemas.microsoft.com/office/drawing/2014/main" id="{7976057B-EA14-45F1-81CC-066A41645B11}"/>
+              </a:ext>
+            </a:extLst>
+          </p:cNvPr>
+          <p:cNvSpPr txBox="1"/>
+          <p:nvPr/>
+        </p:nvSpPr>
+        <p:spPr>
+          <a:xfrm>
+            <a:off x="3941515" y="2456502"/>
+            <a:ext cx="463268" cy="215444"/>
+          </a:xfrm>
+          <a:prstGeom prst="rect">
+            <a:avLst/>
+          </a:prstGeom>
+          <a:noFill/>
+        </p:spPr>
+        <p:txBody>
+          <a:bodyPr wrap="none" lIns="0" tIns="0" rIns="0" bIns="0" rtlCol="0">
+            <a:spAutoFit/>
+          </a:bodyPr>
+          <a:lstStyle/>
+          <a:p>
+            <a:r>
+              <a:rPr lang="en-US" sz="1400" i="1" dirty="0" err="1">
+                <a:solidFill>
+                  <a:schemeClr val="tx2">
+                    <a:lumMod val="75000"/>
+                  </a:schemeClr>
+                </a:solidFill>
+              </a:rPr>
+              <a:t>i_gear</a:t>
+            </a:r>
+            <a:endParaRPr lang="de-AT" sz="1400" i="1" dirty="0">
+              <a:solidFill>
+                <a:schemeClr val="tx2">
+                  <a:lumMod val="75000"/>
+                </a:schemeClr>
+              </a:solidFill>
+            </a:endParaRPr>
+          </a:p>
+        </p:txBody>
+      </p:sp>
+      <p:sp>
+        <p:nvSpPr>
+          <p:cNvPr id="17" name="Textfeld 16">
+            <a:extLst>
+              <a:ext uri="{FF2B5EF4-FFF2-40B4-BE49-F238E27FC236}">
+                <a16:creationId xmlns:a16="http://schemas.microsoft.com/office/drawing/2014/main" id="{19B97C51-AF85-4ACA-BE79-5D34607B71EE}"/>
+              </a:ext>
+            </a:extLst>
+          </p:cNvPr>
+          <p:cNvSpPr txBox="1"/>
+          <p:nvPr/>
+        </p:nvSpPr>
+        <p:spPr>
+          <a:xfrm>
+            <a:off x="6677819" y="2529190"/>
+            <a:ext cx="479298" cy="215444"/>
+          </a:xfrm>
+          <a:prstGeom prst="rect">
+            <a:avLst/>
+          </a:prstGeom>
+          <a:noFill/>
+        </p:spPr>
+        <p:txBody>
+          <a:bodyPr wrap="none" lIns="0" tIns="0" rIns="0" bIns="0" rtlCol="0">
+            <a:spAutoFit/>
+          </a:bodyPr>
+          <a:lstStyle/>
+          <a:p>
+            <a:r>
+              <a:rPr lang="en-US" sz="1400" i="1" dirty="0">
+                <a:solidFill>
+                  <a:schemeClr val="tx2">
+                    <a:lumMod val="75000"/>
+                  </a:schemeClr>
+                </a:solidFill>
+              </a:rPr>
+              <a:t>Inertia</a:t>
+            </a:r>
+            <a:endParaRPr lang="de-AT" sz="1400" i="1" dirty="0">
+              <a:solidFill>
+                <a:schemeClr val="tx2">
+                  <a:lumMod val="75000"/>
+                </a:schemeClr>
+              </a:solidFill>
+            </a:endParaRPr>
+          </a:p>
+        </p:txBody>
+      </p:sp>
+      <p:sp>
+        <p:nvSpPr>
+          <p:cNvPr id="18" name="Textfeld 17">
+            <a:extLst>
+              <a:ext uri="{FF2B5EF4-FFF2-40B4-BE49-F238E27FC236}">
+                <a16:creationId xmlns:a16="http://schemas.microsoft.com/office/drawing/2014/main" id="{18EE2D82-21C2-4D6E-B00E-36BD67E34143}"/>
+              </a:ext>
+            </a:extLst>
+          </p:cNvPr>
+          <p:cNvSpPr txBox="1"/>
+          <p:nvPr/>
+        </p:nvSpPr>
+        <p:spPr>
+          <a:xfrm>
+            <a:off x="6650442" y="2880458"/>
+            <a:ext cx="903517" cy="215444"/>
+          </a:xfrm>
+          <a:prstGeom prst="rect">
+            <a:avLst/>
+          </a:prstGeom>
+          <a:noFill/>
+        </p:spPr>
+        <p:txBody>
+          <a:bodyPr wrap="none" lIns="0" tIns="0" rIns="0" bIns="0" rtlCol="0">
+            <a:spAutoFit/>
+          </a:bodyPr>
+          <a:lstStyle/>
+          <a:p>
+            <a:r>
+              <a:rPr lang="en-US" sz="1400" i="1" dirty="0">
+                <a:solidFill>
+                  <a:schemeClr val="tx2">
+                    <a:lumMod val="75000"/>
+                  </a:schemeClr>
+                </a:solidFill>
+              </a:rPr>
+              <a:t>Power Maps</a:t>
+            </a:r>
+            <a:endParaRPr lang="de-AT" sz="1400" i="1" dirty="0">
+              <a:solidFill>
+                <a:schemeClr val="tx2">
+                  <a:lumMod val="75000"/>
+                </a:schemeClr>
+              </a:solidFill>
+            </a:endParaRPr>
+          </a:p>
+        </p:txBody>
+      </p:sp>
+      <p:sp>
+        <p:nvSpPr>
+          <p:cNvPr id="19" name="Textfeld 18">
+            <a:extLst>
+              <a:ext uri="{FF2B5EF4-FFF2-40B4-BE49-F238E27FC236}">
+                <a16:creationId xmlns:a16="http://schemas.microsoft.com/office/drawing/2014/main" id="{F53A5D76-7566-4379-B56A-E64B2527FE3C}"/>
+              </a:ext>
+            </a:extLst>
+          </p:cNvPr>
+          <p:cNvSpPr txBox="1"/>
+          <p:nvPr/>
+        </p:nvSpPr>
+        <p:spPr>
+          <a:xfrm>
+            <a:off x="6653197" y="3231726"/>
+            <a:ext cx="812787" cy="215444"/>
+          </a:xfrm>
+          <a:prstGeom prst="rect">
+            <a:avLst/>
+          </a:prstGeom>
+          <a:noFill/>
+        </p:spPr>
+        <p:txBody>
+          <a:bodyPr wrap="none" lIns="0" tIns="0" rIns="0" bIns="0" rtlCol="0">
+            <a:spAutoFit/>
+          </a:bodyPr>
+          <a:lstStyle/>
+          <a:p>
+            <a:r>
+              <a:rPr lang="en-US" sz="1400" i="1" dirty="0">
+                <a:solidFill>
+                  <a:schemeClr val="tx2">
+                    <a:lumMod val="75000"/>
+                  </a:schemeClr>
+                </a:solidFill>
+              </a:rPr>
+              <a:t>Drag Curve</a:t>
+            </a:r>
+            <a:endParaRPr lang="de-AT" sz="1400" i="1" dirty="0">
+              <a:solidFill>
+                <a:schemeClr val="tx2">
+                  <a:lumMod val="75000"/>
+                </a:schemeClr>
+              </a:solidFill>
+            </a:endParaRPr>
+          </a:p>
+        </p:txBody>
+      </p:sp>
+      <p:sp>
+        <p:nvSpPr>
+          <p:cNvPr id="23" name="Textfeld 22">
+            <a:extLst>
+              <a:ext uri="{FF2B5EF4-FFF2-40B4-BE49-F238E27FC236}">
+                <a16:creationId xmlns:a16="http://schemas.microsoft.com/office/drawing/2014/main" id="{FEC9FB62-97AA-40E2-953B-6D2360E86FF0}"/>
+              </a:ext>
+            </a:extLst>
+          </p:cNvPr>
+          <p:cNvSpPr txBox="1"/>
+          <p:nvPr/>
+        </p:nvSpPr>
+        <p:spPr>
+          <a:xfrm>
+            <a:off x="1749807" y="2564224"/>
+            <a:ext cx="859210" cy="215444"/>
+          </a:xfrm>
+          <a:prstGeom prst="rect">
+            <a:avLst/>
+          </a:prstGeom>
+          <a:noFill/>
+        </p:spPr>
+        <p:txBody>
+          <a:bodyPr wrap="none" lIns="0" tIns="0" rIns="0" bIns="0" rtlCol="0">
+            <a:spAutoFit/>
+          </a:bodyPr>
+          <a:lstStyle/>
+          <a:p>
+            <a:r>
+              <a:rPr lang="en-US" sz="1400" i="1" dirty="0" err="1">
+                <a:solidFill>
+                  <a:schemeClr val="tx2">
+                    <a:lumMod val="75000"/>
+                  </a:schemeClr>
+                </a:solidFill>
+              </a:rPr>
+              <a:t>n_IEPC_avg</a:t>
+            </a:r>
+            <a:endParaRPr lang="de-AT" sz="1400" i="1" dirty="0">
+              <a:solidFill>
+                <a:schemeClr val="tx2">
+                  <a:lumMod val="75000"/>
+                </a:schemeClr>
+              </a:solidFill>
+            </a:endParaRPr>
+          </a:p>
+        </p:txBody>
+      </p:sp>
+      <p:sp>
+        <p:nvSpPr>
+          <p:cNvPr id="25" name="Textfeld 24">
+            <a:extLst>
+              <a:ext uri="{FF2B5EF4-FFF2-40B4-BE49-F238E27FC236}">
+                <a16:creationId xmlns:a16="http://schemas.microsoft.com/office/drawing/2014/main" id="{587CFD8F-2604-4670-B3AD-6992DF500081}"/>
+              </a:ext>
+            </a:extLst>
+          </p:cNvPr>
+          <p:cNvSpPr txBox="1"/>
+          <p:nvPr/>
+        </p:nvSpPr>
+        <p:spPr>
+          <a:xfrm>
+            <a:off x="1719285" y="3162109"/>
+            <a:ext cx="833562" cy="215444"/>
+          </a:xfrm>
+          <a:prstGeom prst="rect">
+            <a:avLst/>
+          </a:prstGeom>
+          <a:noFill/>
+        </p:spPr>
+        <p:txBody>
+          <a:bodyPr wrap="none" lIns="0" tIns="0" rIns="0" bIns="0" rtlCol="0">
+            <a:spAutoFit/>
+          </a:bodyPr>
+          <a:lstStyle/>
+          <a:p>
+            <a:r>
+              <a:rPr lang="en-US" sz="1400" i="1" dirty="0" err="1">
+                <a:solidFill>
+                  <a:schemeClr val="tx2">
+                    <a:lumMod val="75000"/>
+                  </a:schemeClr>
+                </a:solidFill>
+              </a:rPr>
+              <a:t>T_IEPC_out</a:t>
+            </a:r>
+            <a:endParaRPr lang="de-AT" sz="1400" i="1" dirty="0">
+              <a:solidFill>
+                <a:schemeClr val="tx2">
+                  <a:lumMod val="75000"/>
+                </a:schemeClr>
+              </a:solidFill>
+            </a:endParaRPr>
+          </a:p>
+        </p:txBody>
+      </p:sp>
+      <p:sp>
+        <p:nvSpPr>
+          <p:cNvPr id="26" name="Textfeld 25">
+            <a:extLst>
+              <a:ext uri="{FF2B5EF4-FFF2-40B4-BE49-F238E27FC236}">
+                <a16:creationId xmlns:a16="http://schemas.microsoft.com/office/drawing/2014/main" id="{AAAEB9D4-6DA1-497D-8DE2-885BF111410F}"/>
+              </a:ext>
+            </a:extLst>
+          </p:cNvPr>
+          <p:cNvSpPr txBox="1"/>
+          <p:nvPr/>
+        </p:nvSpPr>
+        <p:spPr>
+          <a:xfrm>
+            <a:off x="5264801" y="2560060"/>
+            <a:ext cx="1142813" cy="215444"/>
+          </a:xfrm>
+          <a:prstGeom prst="rect">
+            <a:avLst/>
+          </a:prstGeom>
+          <a:noFill/>
+        </p:spPr>
+        <p:txBody>
+          <a:bodyPr wrap="none" lIns="0" tIns="0" rIns="0" bIns="0" rtlCol="0">
+            <a:spAutoFit/>
+          </a:bodyPr>
+          <a:lstStyle/>
+          <a:p>
+            <a:r>
+              <a:rPr lang="en-US" sz="1400" i="1" dirty="0" err="1">
+                <a:solidFill>
+                  <a:schemeClr val="tx2">
+                    <a:lumMod val="75000"/>
+                  </a:schemeClr>
+                </a:solidFill>
+              </a:rPr>
+              <a:t>n_IEPC_int_avg</a:t>
+            </a:r>
+            <a:endParaRPr lang="de-AT" sz="1400" i="1" dirty="0">
+              <a:solidFill>
+                <a:schemeClr val="tx2">
+                  <a:lumMod val="75000"/>
+                </a:schemeClr>
+              </a:solidFill>
+            </a:endParaRPr>
+          </a:p>
+        </p:txBody>
+      </p:sp>
+      <p:sp>
+        <p:nvSpPr>
+          <p:cNvPr id="27" name="Textfeld 26">
+            <a:extLst>
+              <a:ext uri="{FF2B5EF4-FFF2-40B4-BE49-F238E27FC236}">
+                <a16:creationId xmlns:a16="http://schemas.microsoft.com/office/drawing/2014/main" id="{1EE71155-AA2C-4004-928C-708E7941235E}"/>
+              </a:ext>
+            </a:extLst>
+          </p:cNvPr>
+          <p:cNvSpPr txBox="1"/>
+          <p:nvPr/>
+        </p:nvSpPr>
+        <p:spPr>
+          <a:xfrm>
+            <a:off x="5391932" y="3160196"/>
+            <a:ext cx="782137" cy="215444"/>
+          </a:xfrm>
+          <a:prstGeom prst="rect">
+            <a:avLst/>
+          </a:prstGeom>
+          <a:noFill/>
+        </p:spPr>
+        <p:txBody>
+          <a:bodyPr wrap="none" lIns="0" tIns="0" rIns="0" bIns="0" rtlCol="0">
+            <a:spAutoFit/>
+          </a:bodyPr>
+          <a:lstStyle/>
+          <a:p>
+            <a:r>
+              <a:rPr lang="en-US" sz="1400" i="1" dirty="0" err="1">
+                <a:solidFill>
+                  <a:schemeClr val="tx2">
+                    <a:lumMod val="75000"/>
+                  </a:schemeClr>
+                </a:solidFill>
+              </a:rPr>
+              <a:t>T_IEPC_int</a:t>
+            </a:r>
+            <a:endParaRPr lang="de-AT" sz="1400" i="1" dirty="0">
+              <a:solidFill>
+                <a:schemeClr val="tx2">
+                  <a:lumMod val="75000"/>
+                </a:schemeClr>
+              </a:solidFill>
+            </a:endParaRPr>
+          </a:p>
+        </p:txBody>
+      </p:sp>
+    </p:spTree>
+    <p:extLst>
+      <p:ext uri="{BB962C8B-B14F-4D97-AF65-F5344CB8AC3E}">
+        <p14:creationId xmlns:p14="http://schemas.microsoft.com/office/powerpoint/2010/main" val="3388675800"/>
+      </p:ext>
+    </p:extLst>
+  </p:cSld>
+  <p:clrMapOvr>
+    <a:masterClrMapping/>
+  </p:clrMapOvr>
+</p:sld>
+</file>
+
 <file path=ppt/slides/slide3.xml><?xml version="1.0" encoding="utf-8"?>
 <p:sld xmlns:a="http://schemas.openxmlformats.org/drawingml/2006/main" xmlns:r="http://schemas.openxmlformats.org/officeDocument/2006/relationships" xmlns:p="http://schemas.openxmlformats.org/presentationml/2006/main">
   <p:cSld>

</xml_diff>